<commit_message>
Point AdaptiveEdu workflow and docs at the new Google Sheets IDs.
Use tab-name mode for Sheets nodes so column options resolve on the new spreadsheets.

Co-authored-by: Cursor <cursoragent@cursor.com>
</commit_message>
<xml_diff>
--- a/AdaptiveEdu_Project_Plan.pptx
+++ b/AdaptiveEdu_Project_Plan.pptx
@@ -14663,7 +14663,7 @@
                 </a:solidFill>
                 <a:latin typeface="Calibri"/>
               </a:rPr>
-              <a:t>https://docs.google.com/spreadsheets/d/1m8rzYDXa7817vFFcd1bqszegV0orMgxA8AyyOEyYl1s</a:t>
+              <a:t>https://docs.google.com/spreadsheets/d/1ddIwenYjiwKryP7Pogxe-7qsjKnTmtfCtAlDoplSn5Q</a:t>
             </a:r>
           </a:p>
         </p:txBody>
@@ -14821,7 +14821,7 @@
                 </a:solidFill>
                 <a:latin typeface="Calibri"/>
               </a:rPr>
-              <a:t>https://docs.google.com/spreadsheets/d/1FUfTrazMkwUSOi1NzrC9D4FKqGhTUJ1KPdb-lLCUyY0</a:t>
+              <a:t>https://docs.google.com/spreadsheets/d/1akeM65odle57kxtR7M5LqFMnxCsHX3M1cJKKltExFEg</a:t>
             </a:r>
           </a:p>
         </p:txBody>
@@ -14979,7 +14979,7 @@
                 </a:solidFill>
                 <a:latin typeface="Calibri"/>
               </a:rPr>
-              <a:t>https://docs.google.com/spreadsheets/d/18C6AQaF5evsGaI4upz1vxbCgnE8jhxJfVfQS3-R5KPk</a:t>
+              <a:t>https://docs.google.com/spreadsheets/d/1II6ckyiKFucKsC38PC_0a9tH1h8H0JZe3qaclLxCExY</a:t>
             </a:r>
           </a:p>
         </p:txBody>

</xml_diff>

<commit_message>
Update live n8n canvas screenshot and sanitized ADAPTIVE_14 export.
Replace the workflow JSON from the working cloud instance (credentials stay in n8n; PDFShift key placeholder only) and refresh PPT/docs canvas evidence of a successful register path.

Co-authored-by: Cursor <cursoragent@cursor.com>
</commit_message>
<xml_diff>
--- a/AdaptiveEdu_Project_Plan.pptx
+++ b/AdaptiveEdu_Project_Plan.pptx
@@ -20153,7 +20153,7 @@
                 </a:solidFill>
                 <a:latin typeface="Calibri"/>
               </a:rPr>
-              <a:t>Live workflow ADAPTIVE_14 (46 nodes)</a:t>
+              <a:t>Live workflow ADAPTIVE_14 (46 nodes) — successful run</a:t>
             </a:r>
           </a:p>
         </p:txBody>
@@ -20218,7 +20218,7 @@
         <p:spPr>
           <a:xfrm>
             <a:off x="228600" y="960120"/>
-            <a:ext cx="11704320" cy="3757808"/>
+            <a:ext cx="11704320" cy="3120390"/>
           </a:xfrm>
           <a:prstGeom prst="rect">
             <a:avLst/>
@@ -20255,7 +20255,7 @@
                 </a:solidFill>
                 <a:latin typeface="Calibri"/>
               </a:rPr>
-              <a:t>Three message types only:  student ID  ·  subject code  ·  answers Excel file</a:t>
+              <a:t>Green path: register / subject list.  Message types: student ID  ·  subject code  ·  answers Excel</a:t>
             </a:r>
           </a:p>
         </p:txBody>

</xml_diff>